<commit_message>
Add Agentic Applications lecture deck and supporting YAML configuration
- Introduced a new PowerPoint presentation for the Agentic Applications lecture, detailing models, tools, and task execution.
- Created a corresponding YAML configuration file to define the structure and content of the lecture deck, including sections on opening the loop, adding a clock, and incorporating a judge.
- The deck covers various aspects of agentic applications, including design decisions, latency considerations, and validation methods.
</commit_message>
<xml_diff>
--- a/ai-engineering/05-graph-engineering/slides/graph-engineering.pptx
+++ b/ai-engineering/05-graph-engineering/slides/graph-engineering.pptx
@@ -2048,7 +2048,7 @@
           <a:lstStyle/>
           <a:p>
             <a:r>
-              <a:t>In the book's translation lab the glossary agent mistranslated reasoning. The translator applied it faithfully, and the proofreader, checking against the glossary, saw perfect consistency. Every stage did its job and the error survived all of them. Hence the fix: a reviewer who reads the output against the source.</a:t>
+              <a:t>In the book's translation lab the glossary agent mistranslated reasoning. The translator applied it faithfully, and the proofreader, checking against the glossary, saw perfect consistency. Every stage did its job and the error survived all of them. Hence the fix: a reviewer who reads the output against the source. The 17.2 and 4.4 are error counts relative to a single agent, and Kim et al. read them as descriptive, since amplification did not predict success in their regression.</a:t>
             </a:r>
           </a:p>
           <a:p/>
@@ -2650,7 +2650,7 @@
           <a:lstStyle/>
           <a:p>
             <a:r>
-              <a:t>Evidence often belongs on the edge. In the book's rare-disease graph, each disease and phenotype link carries its reference and frequency as properties, and that single fact is why the chapter picks a property graph over RDF. Type 1 diabetes keeps two IDs, disease and phenotype, because its role depends on context.</a:t>
+              <a:t>This is the SEC graph we will build. Evidence often belongs on the edge. In the book's rare-disease graph, each disease and phenotype link carries its reference and frequency as properties, and that single fact is why the chapter picks a property graph over RDF. Type 1 diabetes keeps two IDs, disease and phenotype, because its role depends on context.</a:t>
             </a:r>
           </a:p>
           <a:p/>
@@ -21734,7 +21734,7 @@
       </p:sp>
       <p:pic>
         <p:nvPicPr>
-          <p:cNvPr id="14" name="Picture 13" descr="li-ai-agents-in-depth-fig10-1-4865542496402175994-4537469623369892488.jpg"/>
+          <p:cNvPr id="14" name="Picture 13" descr="li-ai-agents-in-depth-fig10-1-4090164658217113067-4208216384343912543.jpg"/>
           <p:cNvPicPr>
             <a:picLocks noChangeAspect="1"/>
           </p:cNvPicPr>
@@ -34723,8 +34723,8 @@
         </p:nvSpPr>
         <p:spPr>
           <a:xfrm>
-            <a:off x="803768" y="1417320"/>
-            <a:ext cx="5550523" cy="3712463"/>
+            <a:off x="1030318" y="1417320"/>
+            <a:ext cx="5097423" cy="3712463"/>
           </a:xfrm>
           <a:prstGeom prst="rect">
             <a:avLst/>
@@ -34763,7 +34763,7 @@
       </p:sp>
       <p:pic>
         <p:nvPicPr>
-          <p:cNvPr id="14" name="Picture 13" descr="kollegger-knowledge-graphs-for-rag-relationship-properties-4670970900893234906.jpg"/>
+          <p:cNvPr id="14" name="Picture 13" descr="kollegger-knowledge-graphs-for-rag-sec-graph-schema-2054565072574611712.jpg"/>
           <p:cNvPicPr>
             <a:picLocks noChangeAspect="1"/>
           </p:cNvPicPr>
@@ -34777,8 +34777,8 @@
         </p:blipFill>
         <p:spPr>
           <a:xfrm>
-            <a:off x="858632" y="1472184"/>
-            <a:ext cx="5440795" cy="3602735"/>
+            <a:off x="1085182" y="1472184"/>
+            <a:ext cx="4987695" cy="3602735"/>
           </a:xfrm>
           <a:prstGeom prst="rect">
             <a:avLst/>
@@ -34793,7 +34793,7 @@
         </p:nvSpPr>
         <p:spPr>
           <a:xfrm>
-            <a:off x="502920" y="5212080"/>
+            <a:off x="502920" y="5212079"/>
             <a:ext cx="6152220" cy="365760"/>
           </a:xfrm>
           <a:prstGeom prst="rect">
@@ -34969,7 +34969,7 @@
         <p:spPr>
           <a:xfrm>
             <a:off x="7340940" y="1911095"/>
-            <a:ext cx="4347834" cy="694943"/>
+            <a:ext cx="4347834" cy="996696"/>
           </a:xfrm>
           <a:prstGeom prst="rect">
             <a:avLst/>
@@ -35003,7 +35003,34 @@
                 </a:solidFill>
                 <a:latin typeface="Helvetica Neue"/>
               </a:rPr>
-              <a:t> are typed and directed, and carry properties too</a:t>
+              <a:t> are typed and directed, and carry properties: </a:t>
+            </a:r>
+            <a:r>
+              <a:rPr sz="1620" i="0" b="0">
+                <a:solidFill>
+                  <a:srgbClr val="0F7490"/>
+                </a:solidFill>
+                <a:latin typeface="Menlo"/>
+              </a:rPr>
+              <a:t>value</a:t>
+            </a:r>
+            <a:r>
+              <a:rPr sz="1800" i="0" b="0">
+                <a:solidFill>
+                  <a:srgbClr val="1E293B"/>
+                </a:solidFill>
+                <a:latin typeface="Helvetica Neue"/>
+              </a:rPr>
+              <a:t> sits on </a:t>
+            </a:r>
+            <a:r>
+              <a:rPr sz="1620" i="0" b="0">
+                <a:solidFill>
+                  <a:srgbClr val="0F7490"/>
+                </a:solidFill>
+                <a:latin typeface="Menlo"/>
+              </a:rPr>
+              <a:t>OWNS_STOCK_IN</a:t>
             </a:r>
           </a:p>
         </p:txBody>
@@ -35016,7 +35043,7 @@
         </p:nvSpPr>
         <p:spPr>
           <a:xfrm>
-            <a:off x="7020900" y="2738628"/>
+            <a:off x="7020900" y="3040380"/>
             <a:ext cx="96012" cy="96012"/>
           </a:xfrm>
           <a:prstGeom prst="rect">
@@ -35060,7 +35087,7 @@
         </p:nvSpPr>
         <p:spPr>
           <a:xfrm>
-            <a:off x="7340940" y="2651760"/>
+            <a:off x="7340940" y="2953512"/>
             <a:ext cx="4347834" cy="694943"/>
           </a:xfrm>
           <a:prstGeom prst="rect">
@@ -35108,7 +35135,7 @@
         </p:nvSpPr>
         <p:spPr>
           <a:xfrm>
-            <a:off x="7020900" y="3479291"/>
+            <a:off x="7020900" y="3781044"/>
             <a:ext cx="96012" cy="96012"/>
           </a:xfrm>
           <a:prstGeom prst="rect">
@@ -35152,7 +35179,7 @@
         </p:nvSpPr>
         <p:spPr>
           <a:xfrm>
-            <a:off x="7340940" y="3392423"/>
+            <a:off x="7340940" y="3694176"/>
             <a:ext cx="4347834" cy="393191"/>
           </a:xfrm>
           <a:prstGeom prst="rect">
@@ -39189,7 +39216,7 @@
       </p:sp>
       <p:pic>
         <p:nvPicPr>
-          <p:cNvPr id="14" name="Picture 13" descr="kollegger-knowledge-graphs-for-rag-extract-enhance-expand-4924723180762686328.jpg"/>
+          <p:cNvPr id="14" name="Picture 13" descr="kollegger-knowledge-graphs-for-rag-extract-enhance-expand-3183134450415555640.jpg"/>
           <p:cNvPicPr>
             <a:picLocks noChangeAspect="1"/>
           </p:cNvPicPr>
@@ -40218,7 +40245,7 @@
       </p:sp>
       <p:pic>
         <p:nvPicPr>
-          <p:cNvPr id="14" name="Picture 13" descr="langchain-langgraph-docs-workflows-vs-agent-603370678299354668.jpg"/>
+          <p:cNvPr id="14" name="Picture 13" descr="langchain-langgraph-docs-workflows-vs-agent-5773793843898208957.jpg"/>
           <p:cNvPicPr>
             <a:picLocks noChangeAspect="1"/>
           </p:cNvPicPr>
@@ -55581,7 +55608,7 @@
       </p:sp>
       <p:pic>
         <p:nvPicPr>
-          <p:cNvPr id="14" name="Picture 13" descr="kim-2025-scaling-agent-systems-fig2-4865193809155543405.jpg"/>
+          <p:cNvPr id="14" name="Picture 13" descr="kim-2025-scaling-agent-systems-fig2-6468166244238961163.jpg"/>
           <p:cNvPicPr>
             <a:picLocks noChangeAspect="1"/>
           </p:cNvPicPr>

</xml_diff>